<commit_message>
Record verified pipeline and first complete job run, update five-minute English presentation
</commit_message>
<xml_diff>
--- a/src/transformations/gold/Applebees_Phase2_EN.pptx
+++ b/src/transformations/gold/Applebees_Phase2_EN.pptx
@@ -2,22 +2,22 @@
 <file path=ppt/presentation.xml><?xml version="1.0" encoding="utf-8"?>
 <p:presentation xmlns:p="http://schemas.openxmlformats.org/presentationml/2006/main">
   <p:sldMasterIdLst>
-    <p:sldMasterId xmlns:r="http://schemas.openxmlformats.org/officeDocument/2006/relationships" id="2147483648" r:id="Re5aa2923425146dc"/>
+    <p:sldMasterId xmlns:r="http://schemas.openxmlformats.org/officeDocument/2006/relationships" id="2147483648" r:id="Rf79456efadf6471d"/>
   </p:sldMasterIdLst>
   <p:notesMasterIdLst>
-    <p:notesMasterId xmlns:r="http://schemas.openxmlformats.org/officeDocument/2006/relationships" r:id="R83b7622693384074"/>
+    <p:notesMasterId xmlns:r="http://schemas.openxmlformats.org/officeDocument/2006/relationships" r:id="Rc93edbc6d9af4f28"/>
   </p:notesMasterIdLst>
   <p:sldIdLst>
-    <p:sldId xmlns:r="http://schemas.openxmlformats.org/officeDocument/2006/relationships" id="256" r:id="Rd573f34a02c24b60"/>
-    <p:sldId xmlns:r="http://schemas.openxmlformats.org/officeDocument/2006/relationships" id="257" r:id="R27cf5a93784b40a5"/>
-    <p:sldId xmlns:r="http://schemas.openxmlformats.org/officeDocument/2006/relationships" id="258" r:id="Rbf9d9c95c4fc42b6"/>
-    <p:sldId xmlns:r="http://schemas.openxmlformats.org/officeDocument/2006/relationships" id="259" r:id="R782fc888ce2b4c42"/>
-    <p:sldId xmlns:r="http://schemas.openxmlformats.org/officeDocument/2006/relationships" id="260" r:id="R2d0cbab7a1004a2c"/>
-    <p:sldId xmlns:r="http://schemas.openxmlformats.org/officeDocument/2006/relationships" id="261" r:id="R1b95ec2540524a7d"/>
-    <p:sldId xmlns:r="http://schemas.openxmlformats.org/officeDocument/2006/relationships" id="262" r:id="Rb0365c0c52d44607"/>
-    <p:sldId xmlns:r="http://schemas.openxmlformats.org/officeDocument/2006/relationships" id="263" r:id="R0a73d28a07894595"/>
-    <p:sldId xmlns:r="http://schemas.openxmlformats.org/officeDocument/2006/relationships" id="264" r:id="R9a4cbaf1571d4471"/>
-    <p:sldId xmlns:r="http://schemas.openxmlformats.org/officeDocument/2006/relationships" id="265" r:id="R7ce130f2f6ca4a9d"/>
+    <p:sldId xmlns:r="http://schemas.openxmlformats.org/officeDocument/2006/relationships" id="256" r:id="R0a13d41a29f04618"/>
+    <p:sldId xmlns:r="http://schemas.openxmlformats.org/officeDocument/2006/relationships" id="257" r:id="Rccd3758597b94d88"/>
+    <p:sldId xmlns:r="http://schemas.openxmlformats.org/officeDocument/2006/relationships" id="258" r:id="Ra9cb911039b141b2"/>
+    <p:sldId xmlns:r="http://schemas.openxmlformats.org/officeDocument/2006/relationships" id="259" r:id="R48ba666e5ffe4f1b"/>
+    <p:sldId xmlns:r="http://schemas.openxmlformats.org/officeDocument/2006/relationships" id="260" r:id="R6bdfa6ddbbfb40cb"/>
+    <p:sldId xmlns:r="http://schemas.openxmlformats.org/officeDocument/2006/relationships" id="261" r:id="R64165a722f064151"/>
+    <p:sldId xmlns:r="http://schemas.openxmlformats.org/officeDocument/2006/relationships" id="262" r:id="R643a922609794fc7"/>
+    <p:sldId xmlns:r="http://schemas.openxmlformats.org/officeDocument/2006/relationships" id="263" r:id="Raa9ced9752884d32"/>
+    <p:sldId xmlns:r="http://schemas.openxmlformats.org/officeDocument/2006/relationships" id="264" r:id="R65c91c2871e54e7e"/>
+    <p:sldId xmlns:r="http://schemas.openxmlformats.org/officeDocument/2006/relationships" id="265" r:id="R720477d37a53451e"/>
   </p:sldIdLst>
   <p:sldSz cx="12192000" cy="6858000"/>
   <p:notesSz cx="6858000" cy="9144000"/>
@@ -451,7 +451,7 @@
           <a:lstStyle xmlns:a="http://schemas.openxmlformats.org/drawingml/2006/main"/>
           <a:p xmlns:a="http://schemas.openxmlformats.org/drawingml/2006/main">
             <a:r>
-              <a:t>00:00–00:25. Imagine reviewing more than two million restaurant checks. Which ones deserve attention, and can we trust the numbers behind that decision? Our Phase 2 deliverable builds the data foundation for answering that question. We audited 2,142,846 checks from 127 locations over 115 days. I will explain the workflow, its quality controls and the operational decisions it supports.</a:t>
+              <a:t>00:00–00:25. If you flagged a restaurant check as suspicious, could you trace every number back to its source? Our Phase 2 pipeline provides that foundation. We processed 2,142,846 checks from 127 locations across 115 days. Today I will show how the workflow preserves the data, validates its outputs and supports focused operational review.</a:t>
             </a:r>
           </a:p>
           <a:p xmlns:a="http://schemas.openxmlformats.org/drawingml/2006/main">
@@ -461,7 +461,7 @@
           </a:p>
           <a:p xmlns:a="http://schemas.openxmlformats.org/drawingml/2006/main">
             <a:r>
-              <a:t>Source: source_audit.json. New Lakeflow runtime remains pending.</a:t>
+              <a:t>Source and scope: runtime_evidence.json, runtime_job_1_validation.csv and source_audit.json. Scope: 2026-04-28 through 2026-08-20.</a:t>
             </a:r>
           </a:p>
         </p:txBody>
@@ -531,7 +531,7 @@
           <a:lstStyle xmlns:a="http://schemas.openxmlformats.org/drawingml/2006/main"/>
           <a:p xmlns:a="http://schemas.openxmlformats.org/drawingml/2006/main">
             <a:r>
-              <a:t>Questions only. Do not claim deployment until actual Databricks evidence exists. Runtime access is currently blocked for automated browser control and the MCP integration is not connectable in this environment. Source: RUBRIC_EVIDENCE.md.</a:t>
+              <a:t>Evidence: runtime_evidence.json and the two exported validator CSVs. The first automated job matches the earlier accepted manual run. The second complete job remains pending user evidence. Job duration is an observed screenshot value, without a claimed speed improvement.</a:t>
             </a:r>
           </a:p>
         </p:txBody>
@@ -601,7 +601,7 @@
           <a:lstStyle xmlns:a="http://schemas.openxmlformats.org/drawingml/2006/main"/>
           <a:p xmlns:a="http://schemas.openxmlformats.org/drawingml/2006/main">
             <a:r>
-              <a:t>00:25–01:00. The source is a fixed export of complete JSON arrays. Silver standardizes types and checks dates, references and identifiers. It keeps unusable records in quarantine, with reasons, rather than silently deleting them. Gold prepares the business metrics. A separate validation task reconciles those outputs before a run is accepted. We preserve source-file lineage throughout, and keep the historical EDA in a separate schema for comparison.</a:t>
+              <a:t>00:25–01:00. The source contains complete daily JSON arrays. Our first processing attempt exceeded the JSON reader’s memory. We added a preparation task that reads one check at a time and writes smaller files, with one check per JSON line. Silver standardizes fields and enriches them with location and channel references. Gold prepares reporting metrics. A separate acceptance task reconciles the results. Every stage retains the original file lineage.</a:t>
             </a:r>
           </a:p>
           <a:p xmlns:a="http://schemas.openxmlformats.org/drawingml/2006/main">
@@ -611,7 +611,7 @@
           </a:p>
           <a:p xmlns:a="http://schemas.openxmlformats.org/drawingml/2006/main">
             <a:r>
-              <a:t>Source: mv_checks_cleaned.py and both Gold SQL libraries. New Lakeflow runtime remains pending.</a:t>
+              <a:t>Source and scope: prepare_checks_jsonl_source.py, mv_checks_cleaned.py and the two Gold SQL libraries. Preparation source inventory SHA256 matches the independent audit.</a:t>
             </a:r>
           </a:p>
         </p:txBody>
@@ -681,7 +681,7 @@
           <a:lstStyle xmlns:a="http://schemas.openxmlformats.org/drawingml/2006/main"/>
           <a:p xmlns:a="http://schemas.openxmlformats.org/drawingml/2006/main">
             <a:r>
-              <a:t>01:00–01:40. The transformations protect the meaning of the data. A check is identified by date, location and check ID together. Payments and item discounts become separate child tables. Exploding both arrays in one join could multiply records and inflate totals. A check’s tip is the sum of its payment Gratuity values. We compare the magnitude of that sum because the usual sign is negative. Reference joins add readable location and channel labels without changing the check population.</a:t>
+              <a:t>01:00–01:40. The transformations preserve the meaning of a check. We identify it with business date, location and check ID together. Payments and discounts become separate child tables, so expanding one array cannot multiply the other. A check’s tip equals the sum of its payment Gratuity values. We compare the magnitude of that sum because the usual source sign is negative. We also keep ticket discounts separate from item discounts until the business confirms whether their amounts overlap.</a:t>
             </a:r>
           </a:p>
           <a:p xmlns:a="http://schemas.openxmlformats.org/drawingml/2006/main">
@@ -691,7 +691,7 @@
           </a:p>
           <a:p xmlns:a="http://schemas.openxmlformats.org/drawingml/2006/main">
             <a:r>
-              <a:t>Source: DATA_CONTRACT.md. New Lakeflow runtime remains pending.</a:t>
+              <a:t>Source and scope: DATA_CONTRACT.md and mv_checks_cleaned.py. EmployeeId in a payment identifies its actor, without a verified waiter-role mapping.</a:t>
             </a:r>
           </a:p>
         </p:txBody>
@@ -761,7 +761,7 @@
           <a:lstStyle xmlns:a="http://schemas.openxmlformats.org/drawingml/2006/main"/>
           <a:p xmlns:a="http://schemas.openxmlformats.org/drawingml/2006/main">
             <a:r>
-              <a:t>01:40–02:20. Quality rules specify an action. Critical reference problems fail publication. Unusable checks go to quarantine, and a nonempty quarantine fails the acceptance gate until review. Empty payment lists remain operational exceptions: they mean no payment record exists in that list, not that a customer necessarily failed to pay. Our independent audit found 3,856 such checks and no duplicate composite keys. Runtime validation also checks that no source rows disappear and that child-event counts and payment sums reconcile.</a:t>
+              <a:t>01:40–02:20. Each quality rule has a defined response. Invalid reference dimensions stop publication. Unusable checks retain their evidence in quarantine, and the acceptance task rejects a nonempty quarantine. Empty payment lists remain visible for investigation. The accepted run contains all 2,142,846 checks, with zero duplicate keys, corrupt records or missing dates. We retained 3,856 checks with empty payment lists. That describes missing records in this export. Accounting reconciliation must establish whether customers actually paid.</a:t>
             </a:r>
           </a:p>
           <a:p xmlns:a="http://schemas.openxmlformats.org/drawingml/2006/main">
@@ -771,7 +771,7 @@
           </a:p>
           <a:p xmlns:a="http://schemas.openxmlformats.org/drawingml/2006/main">
             <a:r>
-              <a:t>Source: source_audit.json and mv_quality_metrics.sql. New Lakeflow runtime remains pending.</a:t>
+              <a:t>Source and scope: runtime_job_1_validation.csv and mv_quality_metrics.sql. Blocking results all passed. Empty payment lists remain in the published population.</a:t>
             </a:r>
           </a:p>
         </p:txBody>
@@ -841,7 +841,7 @@
           <a:lstStyle xmlns:a="http://schemas.openxmlformats.org/drawingml/2006/main"/>
           <a:p xmlns:a="http://schemas.openxmlformats.org/drawingml/2006/main">
             <a:r>
-              <a:t>02:20–02:55. The job refreshes the pipeline and runs the validator only after a successful update. We allow one concurrent run and one retry for a transient pipeline failure. A failed data check requires investigation. Audit records use run ID plus metric, so retrying the validator does not duplicate audit rows. A second unchanged-source run tests consistency against the prior accepted run. The daily schedule remains paused. Actual run IDs and durations must come from Databricks.</a:t>
+              <a:t>02:20–02:55. The job runs three tasks in order: prepare the files, refresh the pipeline, then validate its outputs. Each task requires the previous task to succeed. The first complete job finished successfully in 19 minutes and 34 seconds. All 28 audit results passed. Its source and published-check fingerprints matched the prior accepted manual run. Bounded retries handle processing failures. Failed data checks require review, and the job remains manually triggered during verification.</a:t>
             </a:r>
           </a:p>
           <a:p xmlns:a="http://schemas.openxmlformats.org/drawingml/2006/main">
@@ -851,7 +851,7 @@
           </a:p>
           <a:p xmlns:a="http://schemas.openxmlformats.org/drawingml/2006/main">
             <a:r>
-              <a:t>Source: daily_orchestration_job.yml and validate_pipeline.py. New Lakeflow runtime remains pending.</a:t>
+              <a:t>Source and scope: runtime_evidence.json and runtime_job_1_validation.csv. Job ID 54448068766203. Run ID 469997930036472. Screenshot duration 19m 34s. All 28 audit rows passed, including 24 blocking results. A second full job run is still pending evidence.</a:t>
             </a:r>
           </a:p>
         </p:txBody>
@@ -921,7 +921,7 @@
           <a:lstStyle xmlns:a="http://schemas.openxmlformats.org/drawingml/2006/main"/>
           <a:p xmlns:a="http://schemas.openxmlformats.org/drawingml/2006/main">
             <a:r>
-              <a:t>02:55–03:30. We selected the engineering features for this workload. Batch fits a static historical export. Materialized views store computed results for repeated analysis. Liquid clustering organizes valid checks around date and location filters, but we will measure query profiles before claiming a speed improvement. Expectations give each quality rule a clear warn or fail policy. Streaming remains a future option when a reliable append-only feed exists.</a:t>
+              <a:t>02:55–03:30. Our engineering choices fit the current source. Batch suits a fixed historical export. Materialized views store computed reporting results and refresh them through Lakeflow. Liquid clustering uses business date and location, which match common filters. Query profiles are still needed to measure its performance benefit. Expectations distinguish monitored exceptions from blocking integrity failures. Preparation reuses verified output files, but still reads source and output bytes to check their hashes. Incremental ingestion is a future improvement.</a:t>
             </a:r>
           </a:p>
           <a:p xmlns:a="http://schemas.openxmlformats.org/drawingml/2006/main">
@@ -931,7 +931,7 @@
           </a:p>
           <a:p xmlns:a="http://schemas.openxmlformats.org/drawingml/2006/main">
             <a:r>
-              <a:t>Source: Official Databricks documentation linked in README. New Lakeflow runtime remains pending.</a:t>
+              <a:t>Source and scope: README.md engineering choices and https://docs.databricks.com/aws/en/ldp/concepts/refresh. Clustering configuration is implemented in code. No measured acceleration, cost reduction or full incremental-ingestion claim.</a:t>
             </a:r>
           </a:p>
         </p:txBody>
@@ -1001,7 +1001,7 @@
           <a:lstStyle xmlns:a="http://schemas.openxmlformats.org/drawingml/2006/main"/>
           <a:p xmlns:a="http://schemas.openxmlformats.org/drawingml/2006/main">
             <a:r>
-              <a:t>03:30–04:20. The baseline supports a focused operational question. Locations 87, 1 and 141 account for 71.08 percent of checks whose payment list is empty. That is the share of all missing-payment cases, not the missing-payment rate inside each location. We would prioritize source-system reconciliation there and compare local rates before interpreting concentration. Across all checks, 268,590 have a discount, a weighted rate of 12.53 percent. Gold makes those denominators explicit. These findings come from the audited source and historical EDA. The new pipeline still needs runtime evidence.</a:t>
+              <a:t>03:30–04:20. The data supports a practical investigation priority. In the audited source and Week 4 analysis, locations 87, 1 and 141 account for 71.08 percent of checks with empty payment lists. That is their share of missing-payment cases. Their local missing-payment rates answer a separate question. We would reconcile the source-system records at those locations first. The accepted Gold coverage also confirms 268,590 discounted checks, or 12.53 percent of all checks. Explicit denominators help the business compare locations fairly and investigate exceptions without treating concentration as proof of misconduct.</a:t>
             </a:r>
           </a:p>
           <a:p xmlns:a="http://schemas.openxmlformats.org/drawingml/2006/main">
@@ -1011,7 +1011,7 @@
           </a:p>
           <a:p xmlns:a="http://schemas.openxmlformats.org/drawingml/2006/main">
             <a:r>
-              <a:t>Source: source_audit.json and historical source-linked aggregate reports. New Lakeflow runtime remains pending.</a:t>
+              <a:t>Source and scope: Location concentration: historical_reports_week4_tickets_sin_pago_por_sucursal.csv and source audit. Runtime coverage: runtime_job_1_validation.csv. Specific location concentration still uses the historical baseline until the Gold query export is captured.</a:t>
             </a:r>
           </a:p>
         </p:txBody>
@@ -1081,7 +1081,7 @@
           <a:lstStyle xmlns:a="http://schemas.openxmlformats.org/drawingml/2006/main"/>
           <a:p xmlns:a="http://schemas.openxmlformats.org/drawingml/2006/main">
             <a:r>
-              <a:t>04:20–05:00. Our value is a repeatable foundation for investigation: each metric has a defined population, and each exception has a source and handling policy. The repository, transformations, quality rules and job definition are prepared. Fifteen local checks pass, and the full-source audit reproduces the baseline. The remaining acceptance step is to execute the pipeline and job in Databricks, repeat the run unchanged, and capture the results. Then we can prioritize operational review and develop anomaly models with a clearer understanding of data quality.</a:t>
+              <a:t>04:20–05:00. We now have a working workflow with traceable data and a passing acceptance audit. Payment and discount event counts reconcile with their parent checks, and the repeat test preserved the published-check fingerprint. The next business step is to resolve missing-payment records and confirm discount definitions and permissions. The next engineering step is to verify the second complete job run and measure each task’s cost and duration. This gives the team a reliable starting point for investigation and future anomaly models.</a:t>
             </a:r>
           </a:p>
           <a:p xmlns:a="http://schemas.openxmlformats.org/drawingml/2006/main">
@@ -1091,7 +1091,7 @@
           </a:p>
           <a:p xmlns:a="http://schemas.openxmlformats.org/drawingml/2006/main">
             <a:r>
-              <a:t>Source: RUBRIC_EVIDENCE.md. New Lakeflow runtime remains pending.</a:t>
+              <a:t>Source and scope: runtime_evidence.json, runtime_job_1_validation.csv and RUBRIC_EVIDENCE.md. Fingerprint scope covers selected source fields and published checks. Gold totals reconcile separately. Second full job and performance evidence remain pending.</a:t>
             </a:r>
           </a:p>
         </p:txBody>
@@ -3604,12 +3604,12 @@
   </p:cSld>
   <p:clrMap bg1="lt1" tx1="dk1" bg2="lt2" tx2="dk2" accent1="accent1" accent2="accent2" accent3="accent3" accent4="accent4" accent5="accent5" accent6="accent6" hlink="hlink" folHlink="folHlink"/>
   <p:sldLayoutIdLst>
-    <p:sldLayoutId xmlns:r="http://schemas.openxmlformats.org/officeDocument/2006/relationships" id="2147483649" r:id="R308bb3813b7245b0"/>
-    <p:sldLayoutId xmlns:r="http://schemas.openxmlformats.org/officeDocument/2006/relationships" id="2147483650" r:id="R3a48f7af65ea4381"/>
-    <p:sldLayoutId xmlns:r="http://schemas.openxmlformats.org/officeDocument/2006/relationships" id="2147483651" r:id="Rb5173475df034734"/>
-    <p:sldLayoutId xmlns:r="http://schemas.openxmlformats.org/officeDocument/2006/relationships" id="2147483652" r:id="Rd151ddd32e83489b"/>
-    <p:sldLayoutId xmlns:r="http://schemas.openxmlformats.org/officeDocument/2006/relationships" id="2147483653" r:id="Rd2ceb90d0d3145c0"/>
-    <p:sldLayoutId xmlns:r="http://schemas.openxmlformats.org/officeDocument/2006/relationships" id="2147483654" r:id="R3d0f0cd7f0dc4fc8"/>
+    <p:sldLayoutId xmlns:r="http://schemas.openxmlformats.org/officeDocument/2006/relationships" id="2147483649" r:id="R49ee778ddc5c467d"/>
+    <p:sldLayoutId xmlns:r="http://schemas.openxmlformats.org/officeDocument/2006/relationships" id="2147483650" r:id="Rdc59542312e7422b"/>
+    <p:sldLayoutId xmlns:r="http://schemas.openxmlformats.org/officeDocument/2006/relationships" id="2147483651" r:id="Ra3fd7048a89146e0"/>
+    <p:sldLayoutId xmlns:r="http://schemas.openxmlformats.org/officeDocument/2006/relationships" id="2147483652" r:id="R094a8b9e6f824a32"/>
+    <p:sldLayoutId xmlns:r="http://schemas.openxmlformats.org/officeDocument/2006/relationships" id="2147483653" r:id="R570957718daf4754"/>
+    <p:sldLayoutId xmlns:r="http://schemas.openxmlformats.org/officeDocument/2006/relationships" id="2147483654" r:id="R3a8ae92bb4334135"/>
   </p:sldLayoutIdLst>
   <p:txStyles>
     <p:titleStyle>
@@ -5571,7 +5571,7 @@
                   <a:srgbClr val="526078"/>
                 </a:solidFill>
               </a:rPr>
-              <a:t>Source baseline: April 28–August 20, 2026. New Databricks pipeline execution pending.</a:t>
+              <a:t>April 28–August 20, 2026. Pipeline refreshed and validated in Databricks on October 29, 2026.</a:t>
             </a:r>
           </a:p>
         </p:txBody>
@@ -5833,7 +5833,7 @@
                   <a:srgbClr val="334FE4"/>
                 </a:solidFill>
               </a:rPr>
-              <a:t>Completed</a:t>
+              <a:t>Verified</a:t>
             </a:r>
           </a:p>
         </p:txBody>
@@ -5953,7 +5953,7 @@
                   <a:srgbClr val="172342"/>
                 </a:solidFill>
               </a:rPr>
-              <a:t>115 source files audited. 15 local fixture and repository checks passed. Baseline totals reproduced.</a:t>
+              <a:t>115 source files. 24 local tests passed. 28 runtime audit results passed in the complete job.</a:t>
             </a:r>
           </a:p>
         </p:txBody>
@@ -6073,7 +6073,7 @@
                   <a:srgbClr val="334FE4"/>
                 </a:solidFill>
               </a:rPr>
-              <a:t>Prepared</a:t>
+              <a:t>Observed run</a:t>
             </a:r>
           </a:p>
         </p:txBody>
@@ -6193,7 +6193,7 @@
                   <a:srgbClr val="172342"/>
                 </a:solidFill>
               </a:rPr>
-              <a:t>Pipeline libraries, job definition, validation notebook, demonstration SQL and runbook.</a:t>
+              <a:t>Run 469997930036472 succeeded in 19 min 34 s. Input and published-check fingerprints match the prior manual run.</a:t>
             </a:r>
           </a:p>
         </p:txBody>
@@ -6313,7 +6313,7 @@
                   <a:srgbClr val="334FE4"/>
                 </a:solidFill>
               </a:rPr>
-              <a:t>Pending</a:t>
+              <a:t>Remaining evidence</a:t>
             </a:r>
           </a:p>
         </p:txBody>
@@ -6433,7 +6433,7 @@
                   <a:srgbClr val="172342"/>
                 </a:solidFill>
               </a:rPr>
-              <a:t>Databricks pipeline/job execution, second-run consistency and Gold query evidence.</a:t>
+              <a:t>Second complete job run, individual task durations and Gold operational-query export. Clustering benefit remains unmeasured.</a:t>
             </a:r>
           </a:p>
         </p:txBody>
@@ -6699,10 +6699,17 @@
                   <a:srgbClr val="172342"/>
                 </a:solidFill>
               </a:rPr>
-              <a:t>01 SOURCE</a:t>
+              <a:t>01 PREPARATION</a:t>
             </a:r>
           </a:p>
           <a:p xmlns:a="http://schemas.openxmlformats.org/drawingml/2006/main">
+            <a:pPr>
+              <a:defRPr sz="1875">
+                <a:solidFill>
+                  <a:srgbClr val="172342"/>
+                </a:solidFill>
+              </a:defRPr>
+            </a:pPr>
             <a:r>
               <a:t/>
             </a:r>
@@ -6721,7 +6728,7 @@
                   <a:srgbClr val="172342"/>
                 </a:solidFill>
               </a:rPr>
-              <a:t>Multiline JSON checks</a:t>
+              <a:t>One check per JSON line</a:t>
             </a:r>
           </a:p>
           <a:p xmlns:a="http://schemas.openxmlformats.org/drawingml/2006/main">
@@ -6738,7 +6745,7 @@
                   <a:srgbClr val="172342"/>
                 </a:solidFill>
               </a:rPr>
-              <a:t>Location/channel references</a:t>
+              <a:t>Files target 16 MiB</a:t>
             </a:r>
           </a:p>
         </p:txBody>
@@ -7557,7 +7564,7 @@
                   <a:srgbClr val="172342"/>
                 </a:solidFill>
               </a:rPr>
-              <a:t>Every check and child event retains its source file. Historical EDA tables remain separate.</a:t>
+              <a:t>Reference files enrich Silver. Every check and child event retains its original source file.</a:t>
             </a:r>
           </a:p>
         </p:txBody>
@@ -7677,7 +7684,7 @@
                   <a:srgbClr val="526078"/>
                 </a:solidFill>
               </a:rPr>
-              <a:t>Nine Silver datasets and eighteen Gold datasets. The post-run gate controls acceptance.</a:t>
+              <a:t>Nine Silver datasets and eighteen Gold datasets. A separate validation task controls acceptance.</a:t>
             </a:r>
           </a:p>
         </p:txBody>
@@ -10121,7 +10128,7 @@
                   <a:srgbClr val="526078"/>
                 </a:solidFill>
               </a:rPr>
-              <a:t>Source audit: 0 duplicate composite keys; 3,856 empty payment lists; 0 null payment lists.</a:t>
+              <a:t>Runtime: 0 duplicate keys, 0 corrupt records, 0 quarantine. 3,856 empty payment lists retained.</a:t>
             </a:r>
           </a:p>
         </p:txBody>
@@ -10284,8 +10291,8 @@
         </p:nvSpPr>
         <p:spPr>
           <a:xfrm xmlns:a="http://schemas.openxmlformats.org/drawingml/2006/main">
-            <a:off x="666750" y="1619250"/>
-            <a:ext cx="10477500" cy="571500"/>
+            <a:off x="666750" y="1524000"/>
+            <a:ext cx="10477500" cy="476250"/>
           </a:xfrm>
           <a:prstGeom xmlns:a="http://schemas.openxmlformats.org/drawingml/2006/main" prst="rect">
             <a:avLst/>
@@ -10383,7 +10390,7 @@
                   <a:srgbClr val="334FE4"/>
                 </a:solidFill>
               </a:rPr>
-              <a:t>01  Refresh the Lakeflow pipeline</a:t>
+              <a:t>01  Prepare source files</a:t>
             </a:r>
           </a:p>
         </p:txBody>
@@ -10404,8 +10411,8 @@
         </p:nvSpPr>
         <p:spPr>
           <a:xfrm xmlns:a="http://schemas.openxmlformats.org/drawingml/2006/main">
-            <a:off x="666750" y="2333625"/>
-            <a:ext cx="10477500" cy="619125"/>
+            <a:off x="666750" y="2047875"/>
+            <a:ext cx="10477500" cy="523875"/>
           </a:xfrm>
           <a:prstGeom xmlns:a="http://schemas.openxmlformats.org/drawingml/2006/main" prst="rect">
             <a:avLst/>
@@ -10503,7 +10510,7 @@
                   <a:srgbClr val="172342"/>
                 </a:solidFill>
               </a:rPr>
-              <a:t>Lakeflow resolves the internal Silver and Gold dependencies.</a:t>
+              <a:t>Verify source hashes and reuse bounded JSON Lines files.</a:t>
             </a:r>
           </a:p>
         </p:txBody>
@@ -10524,8 +10531,8 @@
         </p:nvSpPr>
         <p:spPr>
           <a:xfrm xmlns:a="http://schemas.openxmlformats.org/drawingml/2006/main">
-            <a:off x="666750" y="3238500"/>
-            <a:ext cx="10477500" cy="571500"/>
+            <a:off x="666750" y="2952750"/>
+            <a:ext cx="10477500" cy="476250"/>
           </a:xfrm>
           <a:prstGeom xmlns:a="http://schemas.openxmlformats.org/drawingml/2006/main" prst="rect">
             <a:avLst/>
@@ -10623,7 +10630,7 @@
                   <a:srgbClr val="334FE4"/>
                 </a:solidFill>
               </a:rPr>
-              <a:t>02  Validate outputs after successful refresh</a:t>
+              <a:t>02  Refresh the Lakeflow pipeline</a:t>
             </a:r>
           </a:p>
         </p:txBody>
@@ -10644,8 +10651,8 @@
         </p:nvSpPr>
         <p:spPr>
           <a:xfrm xmlns:a="http://schemas.openxmlformats.org/drawingml/2006/main">
-            <a:off x="666750" y="3952875"/>
-            <a:ext cx="10477500" cy="619125"/>
+            <a:off x="666750" y="3476625"/>
+            <a:ext cx="10477500" cy="523875"/>
           </a:xfrm>
           <a:prstGeom xmlns:a="http://schemas.openxmlformats.org/drawingml/2006/main" prst="rect">
             <a:avLst/>
@@ -10743,7 +10750,7 @@
                   <a:srgbClr val="172342"/>
                 </a:solidFill>
               </a:rPr>
-              <a:t>A failed reconciliation fails the job and withholds acceptance.</a:t>
+              <a:t>Update nine Silver datasets and eighteen Gold datasets.</a:t>
             </a:r>
           </a:p>
         </p:txBody>
@@ -10764,8 +10771,8 @@
         </p:nvSpPr>
         <p:spPr>
           <a:xfrm xmlns:a="http://schemas.openxmlformats.org/drawingml/2006/main">
-            <a:off x="666750" y="5000625"/>
-            <a:ext cx="10477500" cy="619125"/>
+            <a:off x="666750" y="4381500"/>
+            <a:ext cx="10477500" cy="476250"/>
           </a:xfrm>
           <a:prstGeom xmlns:a="http://schemas.openxmlformats.org/drawingml/2006/main" prst="rect">
             <a:avLst/>
@@ -10779,91 +10786,91 @@
           <a:bodyPr xmlns:a="http://schemas.openxmlformats.org/drawingml/2006/main"/>
           <a:lstStyle xmlns:a="http://schemas.openxmlformats.org/drawingml/2006/main">
             <a:defPPr>
-              <a:defRPr sz="2100" b="0">
-                <a:solidFill>
-                  <a:srgbClr val="172342"/>
+              <a:defRPr sz="2550" b="1">
+                <a:solidFill>
+                  <a:srgbClr val="334FE4"/>
                 </a:solidFill>
               </a:defRPr>
             </a:defPPr>
             <a:lvl1pPr>
-              <a:defRPr sz="2100" b="0">
-                <a:solidFill>
-                  <a:srgbClr val="172342"/>
+              <a:defRPr sz="2550" b="1">
+                <a:solidFill>
+                  <a:srgbClr val="334FE4"/>
                 </a:solidFill>
               </a:defRPr>
             </a:lvl1pPr>
             <a:lvl2pPr>
-              <a:defRPr sz="2100" b="0">
-                <a:solidFill>
-                  <a:srgbClr val="172342"/>
+              <a:defRPr sz="2550" b="1">
+                <a:solidFill>
+                  <a:srgbClr val="334FE4"/>
                 </a:solidFill>
               </a:defRPr>
             </a:lvl2pPr>
             <a:lvl3pPr>
-              <a:defRPr sz="2100" b="0">
-                <a:solidFill>
-                  <a:srgbClr val="172342"/>
+              <a:defRPr sz="2550" b="1">
+                <a:solidFill>
+                  <a:srgbClr val="334FE4"/>
                 </a:solidFill>
               </a:defRPr>
             </a:lvl3pPr>
             <a:lvl4pPr>
-              <a:defRPr sz="2100" b="0">
-                <a:solidFill>
-                  <a:srgbClr val="172342"/>
+              <a:defRPr sz="2550" b="1">
+                <a:solidFill>
+                  <a:srgbClr val="334FE4"/>
                 </a:solidFill>
               </a:defRPr>
             </a:lvl4pPr>
             <a:lvl5pPr>
-              <a:defRPr sz="2100" b="0">
-                <a:solidFill>
-                  <a:srgbClr val="172342"/>
+              <a:defRPr sz="2550" b="1">
+                <a:solidFill>
+                  <a:srgbClr val="334FE4"/>
                 </a:solidFill>
               </a:defRPr>
             </a:lvl5pPr>
             <a:lvl6pPr>
-              <a:defRPr sz="2100" b="0">
-                <a:solidFill>
-                  <a:srgbClr val="172342"/>
+              <a:defRPr sz="2550" b="1">
+                <a:solidFill>
+                  <a:srgbClr val="334FE4"/>
                 </a:solidFill>
               </a:defRPr>
             </a:lvl6pPr>
             <a:lvl7pPr>
-              <a:defRPr sz="2100" b="0">
-                <a:solidFill>
-                  <a:srgbClr val="172342"/>
+              <a:defRPr sz="2550" b="1">
+                <a:solidFill>
+                  <a:srgbClr val="334FE4"/>
                 </a:solidFill>
               </a:defRPr>
             </a:lvl7pPr>
             <a:lvl8pPr>
-              <a:defRPr sz="2100" b="0">
-                <a:solidFill>
-                  <a:srgbClr val="172342"/>
+              <a:defRPr sz="2550" b="1">
+                <a:solidFill>
+                  <a:srgbClr val="334FE4"/>
                 </a:solidFill>
               </a:defRPr>
             </a:lvl8pPr>
             <a:lvl9pPr>
-              <a:defRPr sz="2100" b="0">
-                <a:solidFill>
-                  <a:srgbClr val="172342"/>
+              <a:defRPr sz="2550" b="1">
+                <a:solidFill>
+                  <a:srgbClr val="334FE4"/>
                 </a:solidFill>
               </a:defRPr>
             </a:lvl9pPr>
           </a:lstStyle>
           <a:p xmlns:a="http://schemas.openxmlformats.org/drawingml/2006/main">
             <a:pPr>
-              <a:defRPr sz="2100" b="0">
-                <a:solidFill>
-                  <a:srgbClr val="172342"/>
+              <a:defRPr sz="2550" b="1">
+                <a:solidFill>
+                  <a:srgbClr val="334FE4"/>
                 </a:solidFill>
               </a:defRPr>
             </a:pPr>
             <a:r>
-              <a:rPr sz="2100" b="0">
-                <a:solidFill>
-                  <a:srgbClr val="172342"/>
+              <a:rPr sz="2550" b="1">
+                <a:solidFill>
+                  <a:srgbClr val="334FE4"/>
                 </a:solidFill>
               </a:rPr>
-              <a:t>One concurrent run. One pipeline retry. Data failures require review.</a:t>
+              <a:t>03  Validate outputs</a:t>
             </a:r>
           </a:p>
         </p:txBody>
@@ -10884,8 +10891,8 @@
         </p:nvSpPr>
         <p:spPr>
           <a:xfrm xmlns:a="http://schemas.openxmlformats.org/drawingml/2006/main">
-            <a:off x="666750" y="6191250"/>
-            <a:ext cx="10763250" cy="438150"/>
+            <a:off x="666750" y="4905375"/>
+            <a:ext cx="10477500" cy="523875"/>
           </a:xfrm>
           <a:prstGeom xmlns:a="http://schemas.openxmlformats.org/drawingml/2006/main" prst="rect">
             <a:avLst/>
@@ -10899,91 +10906,212 @@
           <a:bodyPr xmlns:a="http://schemas.openxmlformats.org/drawingml/2006/main"/>
           <a:lstStyle xmlns:a="http://schemas.openxmlformats.org/drawingml/2006/main">
             <a:defPPr>
-              <a:defRPr sz="1350" b="0">
-                <a:solidFill>
-                  <a:srgbClr val="526078"/>
+              <a:defRPr sz="2100" b="0">
+                <a:solidFill>
+                  <a:srgbClr val="172342"/>
                 </a:solidFill>
               </a:defRPr>
             </a:defPPr>
             <a:lvl1pPr>
-              <a:defRPr sz="1350" b="0">
-                <a:solidFill>
-                  <a:srgbClr val="526078"/>
+              <a:defRPr sz="2100" b="0">
+                <a:solidFill>
+                  <a:srgbClr val="172342"/>
                 </a:solidFill>
               </a:defRPr>
             </a:lvl1pPr>
             <a:lvl2pPr>
-              <a:defRPr sz="1350" b="0">
-                <a:solidFill>
-                  <a:srgbClr val="526078"/>
+              <a:defRPr sz="2100" b="0">
+                <a:solidFill>
+                  <a:srgbClr val="172342"/>
                 </a:solidFill>
               </a:defRPr>
             </a:lvl2pPr>
             <a:lvl3pPr>
-              <a:defRPr sz="1350" b="0">
-                <a:solidFill>
-                  <a:srgbClr val="526078"/>
+              <a:defRPr sz="2100" b="0">
+                <a:solidFill>
+                  <a:srgbClr val="172342"/>
                 </a:solidFill>
               </a:defRPr>
             </a:lvl3pPr>
             <a:lvl4pPr>
-              <a:defRPr sz="1350" b="0">
-                <a:solidFill>
-                  <a:srgbClr val="526078"/>
+              <a:defRPr sz="2100" b="0">
+                <a:solidFill>
+                  <a:srgbClr val="172342"/>
                 </a:solidFill>
               </a:defRPr>
             </a:lvl4pPr>
             <a:lvl5pPr>
-              <a:defRPr sz="1350" b="0">
-                <a:solidFill>
-                  <a:srgbClr val="526078"/>
+              <a:defRPr sz="2100" b="0">
+                <a:solidFill>
+                  <a:srgbClr val="172342"/>
                 </a:solidFill>
               </a:defRPr>
             </a:lvl5pPr>
             <a:lvl6pPr>
-              <a:defRPr sz="1350" b="0">
-                <a:solidFill>
-                  <a:srgbClr val="526078"/>
+              <a:defRPr sz="2100" b="0">
+                <a:solidFill>
+                  <a:srgbClr val="172342"/>
                 </a:solidFill>
               </a:defRPr>
             </a:lvl6pPr>
             <a:lvl7pPr>
-              <a:defRPr sz="1350" b="0">
-                <a:solidFill>
-                  <a:srgbClr val="526078"/>
+              <a:defRPr sz="2100" b="0">
+                <a:solidFill>
+                  <a:srgbClr val="172342"/>
                 </a:solidFill>
               </a:defRPr>
             </a:lvl7pPr>
             <a:lvl8pPr>
-              <a:defRPr sz="1350" b="0">
-                <a:solidFill>
-                  <a:srgbClr val="526078"/>
+              <a:defRPr sz="2100" b="0">
+                <a:solidFill>
+                  <a:srgbClr val="172342"/>
                 </a:solidFill>
               </a:defRPr>
             </a:lvl8pPr>
             <a:lvl9pPr>
-              <a:defRPr sz="1350" b="0">
-                <a:solidFill>
-                  <a:srgbClr val="526078"/>
+              <a:defRPr sz="2100" b="0">
+                <a:solidFill>
+                  <a:srgbClr val="172342"/>
                 </a:solidFill>
               </a:defRPr>
             </a:lvl9pPr>
           </a:lstStyle>
           <a:p xmlns:a="http://schemas.openxmlformats.org/drawingml/2006/main">
             <a:pPr>
-              <a:defRPr sz="1350" b="0">
-                <a:solidFill>
-                  <a:srgbClr val="526078"/>
+              <a:defRPr sz="2100" b="0">
+                <a:solidFill>
+                  <a:srgbClr val="172342"/>
                 </a:solidFill>
               </a:defRPr>
             </a:pPr>
             <a:r>
-              <a:rPr sz="1350" b="0">
+              <a:rPr sz="2100" b="0">
+                <a:solidFill>
+                  <a:srgbClr val="172342"/>
+                </a:solidFill>
+              </a:rPr>
+              <a:t>28 audit results passed. First complete job finished in 19 min 34 s.</a:t>
+            </a:r>
+          </a:p>
+        </p:txBody>
+      </p:sp>
+      <p:sp>
+        <p:nvSpPr>
+          <p:cNvPr id="9" name="Runtime policy">
+            <a:extLst xmlns:a="http://schemas.openxmlformats.org/drawingml/2006/main">
+              <a:ext uri="{FF2B5EF4-FFF2-40B4-BE49-F238E27FC236}">
+                <a16:creationId xmlns:a16="http://schemas.microsoft.com/office/drawing/2014/main" id="{4019F3EC-52B1-486D-B873-1F54354E9BDE}"/>
+              </a:ext>
+            </a:extLst>
+          </p:cNvPr>
+          <p:cNvSpPr>
+            <a:spLocks xmlns:a="http://schemas.openxmlformats.org/drawingml/2006/main" noGrp="1"/>
+          </p:cNvSpPr>
+          <p:nvPr/>
+        </p:nvSpPr>
+        <p:spPr>
+          <a:xfrm xmlns:a="http://schemas.openxmlformats.org/drawingml/2006/main">
+            <a:off x="666750" y="6096000"/>
+            <a:ext cx="10763250" cy="571500"/>
+          </a:xfrm>
+          <a:prstGeom xmlns:a="http://schemas.openxmlformats.org/drawingml/2006/main" prst="rect">
+            <a:avLst/>
+          </a:prstGeom>
+          <a:noFill xmlns:a="http://schemas.openxmlformats.org/drawingml/2006/main"/>
+          <a:ln xmlns:a="http://schemas.openxmlformats.org/drawingml/2006/main" w="0">
+            <a:noFill/>
+            <a:prstDash val="solid"/>
+          </a:ln>
+        </p:spPr>
+        <p:txBody>
+          <a:bodyPr xmlns:a="http://schemas.openxmlformats.org/drawingml/2006/main"/>
+          <a:lstStyle xmlns:a="http://schemas.openxmlformats.org/drawingml/2006/main">
+            <a:defPPr>
+              <a:defRPr sz="1350">
                 <a:solidFill>
                   <a:srgbClr val="526078"/>
                 </a:solidFill>
+              </a:defRPr>
+            </a:defPPr>
+            <a:lvl1pPr>
+              <a:defRPr sz="1350">
+                <a:solidFill>
+                  <a:srgbClr val="526078"/>
+                </a:solidFill>
+              </a:defRPr>
+            </a:lvl1pPr>
+            <a:lvl2pPr>
+              <a:defRPr sz="1350">
+                <a:solidFill>
+                  <a:srgbClr val="526078"/>
+                </a:solidFill>
+              </a:defRPr>
+            </a:lvl2pPr>
+            <a:lvl3pPr>
+              <a:defRPr sz="1350">
+                <a:solidFill>
+                  <a:srgbClr val="526078"/>
+                </a:solidFill>
+              </a:defRPr>
+            </a:lvl3pPr>
+            <a:lvl4pPr>
+              <a:defRPr sz="1350">
+                <a:solidFill>
+                  <a:srgbClr val="526078"/>
+                </a:solidFill>
+              </a:defRPr>
+            </a:lvl4pPr>
+            <a:lvl5pPr>
+              <a:defRPr sz="1350">
+                <a:solidFill>
+                  <a:srgbClr val="526078"/>
+                </a:solidFill>
+              </a:defRPr>
+            </a:lvl5pPr>
+            <a:lvl6pPr>
+              <a:defRPr sz="1350">
+                <a:solidFill>
+                  <a:srgbClr val="526078"/>
+                </a:solidFill>
+              </a:defRPr>
+            </a:lvl6pPr>
+            <a:lvl7pPr>
+              <a:defRPr sz="1350">
+                <a:solidFill>
+                  <a:srgbClr val="526078"/>
+                </a:solidFill>
+              </a:defRPr>
+            </a:lvl7pPr>
+            <a:lvl8pPr>
+              <a:defRPr sz="1350">
+                <a:solidFill>
+                  <a:srgbClr val="526078"/>
+                </a:solidFill>
+              </a:defRPr>
+            </a:lvl8pPr>
+            <a:lvl9pPr>
+              <a:defRPr sz="1350">
+                <a:solidFill>
+                  <a:srgbClr val="526078"/>
+                </a:solidFill>
+              </a:defRPr>
+            </a:lvl9pPr>
+          </a:lstStyle>
+          <a:p xmlns:a="http://schemas.openxmlformats.org/drawingml/2006/main">
+            <a:pPr>
+              <a:defRPr sz="1350">
+                <a:solidFill>
+                  <a:srgbClr val="526078"/>
+                </a:solidFill>
+              </a:defRPr>
+            </a:pPr>
+            <a:r>
+              <a:rPr sz="1350">
+                <a:solidFill>
+                  <a:srgbClr val="526078"/>
+                </a:solidFill>
               </a:rPr>
-              <a:t>Proposed schedule: 07:00 America/Mexico_City, paused until validation and rerun tests pass.</a:t>
+              <a:t>Manual trigger. Success dependencies. One processing retry. Validation failures require review.</a:t>
             </a:r>
           </a:p>
         </p:txBody>
@@ -12205,7 +12333,7 @@
                   <a:srgbClr val="526078"/>
                 </a:solidFill>
               </a:rPr>
-              <a:t>A normal refresh request does not establish end-to-end incremental ingestion.</a:t>
+              <a:t>Batch refresh supports this fixed export. Preparation verifies cached files with source hashes.</a:t>
             </a:r>
           </a:p>
         </p:txBody>
@@ -12347,7 +12475,7 @@
                   <a:srgbClr val="334FE4"/>
                 </a:solidFill>
               </a:rPr>
-              <a:t>Operational findings supported by the baseline</a:t>
+              <a:t>Operational findings</a:t>
             </a:r>
           </a:p>
         </p:txBody>
@@ -12490,7 +12618,7 @@
         </p:xfrm>
         <a:graphic xmlns:a="http://schemas.openxmlformats.org/drawingml/2006/main">
           <a:graphicData uri="http://schemas.openxmlformats.org/drawingml/2006/chart">
-            <c:chart xmlns:r="http://schemas.openxmlformats.org/officeDocument/2006/relationships" xmlns:c="http://schemas.openxmlformats.org/drawingml/2006/chart" r:id="Ra7bd4dd8089f4dd2"/>
+            <c:chart xmlns:r="http://schemas.openxmlformats.org/officeDocument/2006/relationships" xmlns:c="http://schemas.openxmlformats.org/drawingml/2006/chart" r:id="R235dd6d78d7349e1"/>
           </a:graphicData>
         </a:graphic>
       </p:graphicFrame>
@@ -12986,7 +13114,7 @@
                   <a:srgbClr val="526078"/>
                 </a:solidFill>
               </a:rPr>
-              <a:t>Source audit / historical EDA baseline. Refresh from accepted Gold before claiming new pipeline results.</a:t>
+              <a:t>Concentration uses source audit and Week 4 EDA. Accepted Gold coverage confirms the total checks and discounts.</a:t>
             </a:r>
           </a:p>
         </p:txBody>
@@ -13128,7 +13256,7 @@
                   <a:srgbClr val="334FE4"/>
                 </a:solidFill>
               </a:rPr>
-              <a:t>Readiness and next decision</a:t>
+              <a:t>Verified execution and next steps</a:t>
             </a:r>
           </a:p>
         </p:txBody>
@@ -13248,7 +13376,7 @@
                   <a:srgbClr val="334FE4"/>
                 </a:solidFill>
               </a:rPr>
-              <a:t>Implemented and checked locally</a:t>
+              <a:t>28 runtime audit results passed</a:t>
             </a:r>
           </a:p>
         </p:txBody>
@@ -13368,7 +13496,7 @@
                   <a:srgbClr val="172342"/>
                 </a:solidFill>
               </a:rPr>
-              <a:t>Repository structure, transformations, quality policies, job configuration and source audit.</a:t>
+              <a:t>All 2,142,846 checks reconcile. Repetition preserved the published-check fingerprint.</a:t>
             </a:r>
           </a:p>
         </p:txBody>
@@ -13488,7 +13616,7 @@
                   <a:srgbClr val="334FE4"/>
                 </a:solidFill>
               </a:rPr>
-              <a:t>Databricks validation is the acceptance step</a:t>
+              <a:t>Operational review</a:t>
             </a:r>
           </a:p>
         </p:txBody>
@@ -13608,7 +13736,7 @@
                   <a:srgbClr val="172342"/>
                 </a:solidFill>
               </a:rPr>
-              <a:t>Run the pipeline and job twice. Capture quality, reconciliation and Gold results.</a:t>
+              <a:t>Reconcile missing payment records and confirm discount permissions before developing risk scores.</a:t>
             </a:r>
           </a:p>
         </p:txBody>
@@ -13728,7 +13856,7 @@
                   <a:srgbClr val="526078"/>
                 </a:solidFill>
               </a:rPr>
-              <a:t>The goal: operational exceptions with evidence behind every metric.</a:t>
+              <a:t>Validated data supports focused review. Business context remains essential.</a:t>
             </a:r>
           </a:p>
         </p:txBody>

</xml_diff>